<commit_message>
fix(templates): place the deck's boxes for a 16:9 page
Co-Authored-By: Claude Sonnet 5 <noreply@anthropic.com>
Co-authored-by: chiruotong <chiruotong@zhishi.local>
</commit_message>
<xml_diff>
--- a/backend/app/domain/documents/templates/project-deck.pptx
+++ b/backend/app/domain/documents/templates/project-deck.pptx
@@ -3105,7 +3105,8 @@
         </p:nvSpPr>
         <p:spPr>
           <a:xfrm>
-            <a:ext cx="11277295" cy="0"/>
+            <a:off x="548640" y="2194560"/>
+            <a:ext cx="11094415" cy="1371600"/>
           </a:xfrm>
         </p:spPr>
         <p:txBody>
@@ -3128,7 +3129,12 @@
             <p:ph type="subTitle" idx="1"/>
           </p:nvPr>
         </p:nvSpPr>
-        <p:spPr/>
+        <p:spPr>
+          <a:xfrm>
+            <a:off x="548640" y="3749039"/>
+            <a:ext cx="11094415" cy="914400"/>
+          </a:xfrm>
+        </p:spPr>
         <p:txBody>
           <a:bodyPr/>
           <a:lstStyle/>
@@ -3169,7 +3175,8 @@
         </p:nvSpPr>
         <p:spPr>
           <a:xfrm>
-            <a:ext cx="11277295" cy="0"/>
+            <a:off x="548640" y="411480"/>
+            <a:ext cx="11094415" cy="914400"/>
           </a:xfrm>
         </p:spPr>
         <p:txBody>
@@ -3177,6 +3184,11 @@
           <a:lstStyle/>
           <a:p>
             <a:r>
+              <a:rPr sz="3200" b="1">
+                <a:solidFill>
+                  <a:srgbClr val="1F4E79"/>
+                </a:solidFill>
+              </a:rPr>
               <a:t>目标与进展概览</a:t>
             </a:r>
           </a:p>
@@ -3192,7 +3204,12 @@
             <p:ph idx="1"/>
           </p:nvPr>
         </p:nvSpPr>
-        <p:spPr/>
+        <p:spPr>
+          <a:xfrm>
+            <a:off x="548640" y="1554480"/>
+            <a:ext cx="11094415" cy="4754880"/>
+          </a:xfrm>
+        </p:spPr>
         <p:txBody>
           <a:bodyPr/>
           <a:lstStyle/>
@@ -3283,7 +3300,8 @@
         </p:nvSpPr>
         <p:spPr>
           <a:xfrm>
-            <a:ext cx="11277295" cy="0"/>
+            <a:off x="548640" y="411480"/>
+            <a:ext cx="11094415" cy="914400"/>
           </a:xfrm>
         </p:spPr>
         <p:txBody>
@@ -3291,6 +3309,11 @@
           <a:lstStyle/>
           <a:p>
             <a:r>
+              <a:rPr sz="3200" b="1">
+                <a:solidFill>
+                  <a:srgbClr val="1F4E79"/>
+                </a:solidFill>
+              </a:rPr>
               <a:t>关键成果</a:t>
             </a:r>
           </a:p>
@@ -3306,7 +3329,12 @@
             <p:ph idx="1"/>
           </p:nvPr>
         </p:nvSpPr>
-        <p:spPr/>
+        <p:spPr>
+          <a:xfrm>
+            <a:off x="548640" y="1554480"/>
+            <a:ext cx="11094415" cy="4754880"/>
+          </a:xfrm>
+        </p:spPr>
         <p:txBody>
           <a:bodyPr/>
           <a:lstStyle/>
@@ -3403,7 +3431,8 @@
         </p:nvSpPr>
         <p:spPr>
           <a:xfrm>
-            <a:ext cx="11277295" cy="0"/>
+            <a:off x="548640" y="411480"/>
+            <a:ext cx="11094415" cy="914400"/>
           </a:xfrm>
         </p:spPr>
         <p:txBody>
@@ -3411,6 +3440,11 @@
           <a:lstStyle/>
           <a:p>
             <a:r>
+              <a:rPr sz="3200" b="1">
+                <a:solidFill>
+                  <a:srgbClr val="1F4E79"/>
+                </a:solidFill>
+              </a:rPr>
               <a:t>问题与风险</a:t>
             </a:r>
           </a:p>
@@ -3426,7 +3460,12 @@
             <p:ph idx="1"/>
           </p:nvPr>
         </p:nvSpPr>
-        <p:spPr/>
+        <p:spPr>
+          <a:xfrm>
+            <a:off x="548640" y="1554480"/>
+            <a:ext cx="11094415" cy="4754880"/>
+          </a:xfrm>
+        </p:spPr>
         <p:txBody>
           <a:bodyPr/>
           <a:lstStyle/>
@@ -3511,7 +3550,8 @@
         </p:nvSpPr>
         <p:spPr>
           <a:xfrm>
-            <a:ext cx="11277295" cy="0"/>
+            <a:off x="548640" y="411480"/>
+            <a:ext cx="11094415" cy="914400"/>
           </a:xfrm>
         </p:spPr>
         <p:txBody>
@@ -3519,6 +3559,11 @@
           <a:lstStyle/>
           <a:p>
             <a:r>
+              <a:rPr sz="3200" b="1">
+                <a:solidFill>
+                  <a:srgbClr val="1F4E79"/>
+                </a:solidFill>
+              </a:rPr>
               <a:t>下一步计划</a:t>
             </a:r>
           </a:p>
@@ -3534,7 +3579,12 @@
             <p:ph idx="1"/>
           </p:nvPr>
         </p:nvSpPr>
-        <p:spPr/>
+        <p:spPr>
+          <a:xfrm>
+            <a:off x="548640" y="1554480"/>
+            <a:ext cx="11094415" cy="4754880"/>
+          </a:xfrm>
+        </p:spPr>
         <p:txBody>
           <a:bodyPr/>
           <a:lstStyle/>
@@ -3619,7 +3669,8 @@
         </p:nvSpPr>
         <p:spPr>
           <a:xfrm>
-            <a:ext cx="11277295" cy="0"/>
+            <a:off x="548640" y="411480"/>
+            <a:ext cx="11094415" cy="914400"/>
           </a:xfrm>
         </p:spPr>
         <p:txBody>
@@ -3627,6 +3678,11 @@
           <a:lstStyle/>
           <a:p>
             <a:r>
+              <a:rPr sz="3200" b="1">
+                <a:solidFill>
+                  <a:srgbClr val="1F4E79"/>
+                </a:solidFill>
+              </a:rPr>
               <a:t>需要的支持</a:t>
             </a:r>
           </a:p>
@@ -3642,7 +3698,12 @@
             <p:ph idx="1"/>
           </p:nvPr>
         </p:nvSpPr>
-        <p:spPr/>
+        <p:spPr>
+          <a:xfrm>
+            <a:off x="548640" y="1554480"/>
+            <a:ext cx="11094415" cy="4754880"/>
+          </a:xfrm>
+        </p:spPr>
         <p:txBody>
           <a:bodyPr/>
           <a:lstStyle/>

</xml_diff>